<commit_message>
comecei a preencher modelos de resumo e apresentação
</commit_message>
<xml_diff>
--- a/Documentos/MODELO PPT ENCIBRAC 2026 (1).pptx
+++ b/Documentos/MODELO PPT ENCIBRAC 2026 (1).pptx
@@ -637,7 +637,7 @@
               <a:pPr>
                 <a:defRPr/>
               </a:pPr>
-              <a:t>22/05/2025</a:t>
+              <a:t>08/10/2026</a:t>
             </a:fld>
             <a:endParaRPr lang="pt-BR"/>
           </a:p>
@@ -850,7 +850,7 @@
               <a:pPr>
                 <a:defRPr/>
               </a:pPr>
-              <a:t>22/05/2025</a:t>
+              <a:t>08/10/2026</a:t>
             </a:fld>
             <a:endParaRPr lang="pt-BR"/>
           </a:p>
@@ -1073,7 +1073,7 @@
               <a:pPr>
                 <a:defRPr/>
               </a:pPr>
-              <a:t>22/05/2025</a:t>
+              <a:t>08/10/2026</a:t>
             </a:fld>
             <a:endParaRPr lang="pt-BR"/>
           </a:p>
@@ -1286,7 +1286,7 @@
               <a:pPr>
                 <a:defRPr/>
               </a:pPr>
-              <a:t>22/05/2025</a:t>
+              <a:t>08/10/2026</a:t>
             </a:fld>
             <a:endParaRPr lang="pt-BR"/>
           </a:p>
@@ -1576,7 +1576,7 @@
               <a:pPr>
                 <a:defRPr/>
               </a:pPr>
-              <a:t>22/05/2025</a:t>
+              <a:t>08/10/2026</a:t>
             </a:fld>
             <a:endParaRPr lang="pt-BR"/>
           </a:p>
@@ -1850,7 +1850,7 @@
               <a:pPr>
                 <a:defRPr/>
               </a:pPr>
-              <a:t>22/05/2025</a:t>
+              <a:t>08/10/2026</a:t>
             </a:fld>
             <a:endParaRPr lang="pt-BR"/>
           </a:p>
@@ -2259,7 +2259,7 @@
               <a:pPr>
                 <a:defRPr/>
               </a:pPr>
-              <a:t>22/05/2025</a:t>
+              <a:t>08/10/2026</a:t>
             </a:fld>
             <a:endParaRPr lang="pt-BR"/>
           </a:p>
@@ -2421,7 +2421,7 @@
               <a:pPr>
                 <a:defRPr/>
               </a:pPr>
-              <a:t>22/05/2025</a:t>
+              <a:t>08/10/2026</a:t>
             </a:fld>
             <a:endParaRPr lang="pt-BR"/>
           </a:p>
@@ -2561,7 +2561,7 @@
               <a:pPr>
                 <a:defRPr/>
               </a:pPr>
-              <a:t>22/05/2025</a:t>
+              <a:t>08/10/2026</a:t>
             </a:fld>
             <a:endParaRPr lang="pt-BR"/>
           </a:p>
@@ -2881,7 +2881,7 @@
               <a:pPr>
                 <a:defRPr/>
               </a:pPr>
-              <a:t>22/05/2025</a:t>
+              <a:t>08/10/2026</a:t>
             </a:fld>
             <a:endParaRPr lang="pt-BR"/>
           </a:p>
@@ -3181,7 +3181,7 @@
               <a:pPr>
                 <a:defRPr/>
               </a:pPr>
-              <a:t>22/05/2025</a:t>
+              <a:t>08/10/2026</a:t>
             </a:fld>
             <a:endParaRPr lang="pt-BR"/>
           </a:p>
@@ -3503,7 +3503,7 @@
               <a:pPr>
                 <a:defRPr/>
               </a:pPr>
-              <a:t>22/05/2025</a:t>
+              <a:t>08/10/2026</a:t>
             </a:fld>
             <a:endParaRPr lang="pt-BR"/>
           </a:p>
@@ -5070,8 +5070,8 @@
         </p:nvSpPr>
         <p:spPr bwMode="auto">
           <a:xfrm>
-            <a:off x="7927675" y="2237462"/>
-            <a:ext cx="3234906" cy="1661993"/>
+            <a:off x="7927674" y="2237462"/>
+            <a:ext cx="3426125" cy="830997"/>
           </a:xfrm>
           <a:prstGeom prst="rect">
             <a:avLst/>
@@ -5209,14 +5209,14 @@
               </a:spcBef>
             </a:pPr>
             <a:r>
-              <a:rPr lang="pt-BR" altLang="pt-BR" sz="1200" b="1">
+              <a:rPr lang="pt-BR" altLang="pt-BR" sz="1200" b="1" dirty="0" err="1">
                 <a:solidFill>
                   <a:srgbClr val="153553"/>
                 </a:solidFill>
                 <a:latin typeface="Verdana" panose="020B0604030504040204" pitchFamily="34" charset="0"/>
                 <a:ea typeface="ＭＳ Ｐゴシック" panose="020B0600070205080204" pitchFamily="34" charset="-128"/>
               </a:rPr>
-              <a:t>Profa</a:t>
+              <a:t>Profª</a:t>
             </a:r>
             <a:r>
               <a:rPr lang="pt-BR" altLang="pt-BR" sz="1200" b="1" dirty="0">
@@ -5226,42 +5226,8 @@
                 <a:latin typeface="Verdana" panose="020B0604030504040204" pitchFamily="34" charset="0"/>
                 <a:ea typeface="ＭＳ Ｐゴシック" panose="020B0600070205080204" pitchFamily="34" charset="-128"/>
               </a:rPr>
-              <a:t>. Renata Costa, Me</a:t>
-            </a:r>
-          </a:p>
-          <a:p>
-            <a:pPr>
-              <a:spcBef>
-                <a:spcPct val="50000"/>
-              </a:spcBef>
-            </a:pPr>
-            <a:r>
-              <a:rPr lang="pt-BR" altLang="pt-BR" sz="1200" b="1" dirty="0">
-                <a:solidFill>
-                  <a:srgbClr val="153553"/>
-                </a:solidFill>
-                <a:latin typeface="Verdana" panose="020B0604030504040204" pitchFamily="34" charset="0"/>
-                <a:ea typeface="ＭＳ Ｐゴシック" panose="020B0600070205080204" pitchFamily="34" charset="-128"/>
-              </a:rPr>
-              <a:t>Profa. Andrea Ono, </a:t>
-            </a:r>
-            <a:r>
-              <a:rPr lang="pt-BR" altLang="pt-BR" sz="1200" b="1" dirty="0" err="1">
-                <a:solidFill>
-                  <a:srgbClr val="153553"/>
-                </a:solidFill>
-                <a:latin typeface="Verdana" panose="020B0604030504040204" pitchFamily="34" charset="0"/>
-                <a:ea typeface="ＭＳ Ｐゴシック" panose="020B0600070205080204" pitchFamily="34" charset="-128"/>
-              </a:rPr>
-              <a:t>Dr</a:t>
-            </a:r>
-            <a:endParaRPr lang="pt-BR" altLang="pt-BR" sz="1200" b="1" dirty="0">
-              <a:solidFill>
-                <a:srgbClr val="153553"/>
-              </a:solidFill>
-              <a:latin typeface="Verdana" panose="020B0604030504040204" pitchFamily="34" charset="0"/>
-              <a:ea typeface="ＭＳ Ｐゴシック" panose="020B0600070205080204" pitchFamily="34" charset="-128"/>
-            </a:endParaRPr>
+              <a:t> Isabella Luiza  S. Santos</a:t>
+            </a:r>
           </a:p>
           <a:p>
             <a:pPr>
@@ -5291,41 +5257,7 @@
                 <a:latin typeface="Verdana" panose="020B0604030504040204" pitchFamily="34" charset="0"/>
                 <a:ea typeface="ＭＳ Ｐゴシック" panose="020B0600070205080204" pitchFamily="34" charset="-128"/>
               </a:rPr>
-              <a:t>Aluno 1</a:t>
-            </a:r>
-          </a:p>
-          <a:p>
-            <a:pPr>
-              <a:spcBef>
-                <a:spcPct val="50000"/>
-              </a:spcBef>
-            </a:pPr>
-            <a:r>
-              <a:rPr lang="pt-BR" altLang="pt-BR" sz="1200" dirty="0">
-                <a:solidFill>
-                  <a:srgbClr val="153553"/>
-                </a:solidFill>
-                <a:latin typeface="Verdana" panose="020B0604030504040204" pitchFamily="34" charset="0"/>
-                <a:ea typeface="ＭＳ Ｐゴシック" panose="020B0600070205080204" pitchFamily="34" charset="-128"/>
-              </a:rPr>
-              <a:t>Aluno 2</a:t>
-            </a:r>
-          </a:p>
-          <a:p>
-            <a:pPr>
-              <a:spcBef>
-                <a:spcPct val="50000"/>
-              </a:spcBef>
-            </a:pPr>
-            <a:r>
-              <a:rPr lang="pt-BR" altLang="pt-BR" sz="1200" dirty="0">
-                <a:solidFill>
-                  <a:srgbClr val="153553"/>
-                </a:solidFill>
-                <a:latin typeface="Verdana" panose="020B0604030504040204" pitchFamily="34" charset="0"/>
-                <a:ea typeface="ＭＳ Ｐゴシック" panose="020B0600070205080204" pitchFamily="34" charset="-128"/>
-              </a:rPr>
-              <a:t>Aluno 3</a:t>
+              <a:t>Nathan Gabriel Nunes dos Santos</a:t>
             </a:r>
           </a:p>
         </p:txBody>
@@ -5492,7 +5424,7 @@
                 <a:latin typeface="Verdana" panose="020B0604030504040204" pitchFamily="34" charset="0"/>
                 <a:ea typeface="ＭＳ Ｐゴシック" panose="020B0600070205080204" pitchFamily="34" charset="-128"/>
               </a:rPr>
-              <a:t>NOME DO CURSO</a:t>
+              <a:t>DESIGN PROFISSIONAL</a:t>
             </a:r>
           </a:p>
         </p:txBody>
@@ -5758,7 +5690,7 @@
                 <a:latin typeface="Verdana" panose="020B0604030504040204" pitchFamily="34" charset="0"/>
                 <a:ea typeface="ＭＳ Ｐゴシック" panose="020B0600070205080204" pitchFamily="34" charset="-128"/>
               </a:rPr>
-              <a:t>2025.1</a:t>
+              <a:t>2026.2</a:t>
             </a:r>
           </a:p>
         </p:txBody>
@@ -10349,15 +10281,6 @@
 </file>
 
 <file path=customXml/item1.xml><?xml version="1.0" encoding="utf-8"?>
-<?mso-contentType ?>
-<FormTemplates xmlns="http://schemas.microsoft.com/sharepoint/v3/contenttype/forms">
-  <Display>DocumentLibraryForm</Display>
-  <Edit>DocumentLibraryForm</Edit>
-  <New>DocumentLibraryForm</New>
-</FormTemplates>
-</file>
-
-<file path=customXml/item2.xml><?xml version="1.0" encoding="utf-8"?>
 <ct:contentTypeSchema xmlns:ct="http://schemas.microsoft.com/office/2006/metadata/contentType" xmlns:ma="http://schemas.microsoft.com/office/2006/metadata/properties/metaAttributes" ct:_="" ma:_="" ma:contentTypeName="Documento" ma:contentTypeID="0x0101001DAED1B117F6894D909B25A69A4597D2" ma:contentTypeVersion="11" ma:contentTypeDescription="Crie um novo documento." ma:contentTypeScope="" ma:versionID="fc0e1081098a96f1fc26b259e7bbb1c8">
   <xsd:schema xmlns:xsd="http://www.w3.org/2001/XMLSchema" xmlns:xs="http://www.w3.org/2001/XMLSchema" xmlns:p="http://schemas.microsoft.com/office/2006/metadata/properties" xmlns:ns2="0cd93fe2-0880-41f5-aab4-f958682b72cb" xmlns:ns3="18000554-2c77-4cf4-9366-a485aa9d7e35" targetNamespace="http://schemas.microsoft.com/office/2006/metadata/properties" ma:root="true" ma:fieldsID="f39cd65ee00b5e4c5dd2756fb7575f2f" ns2:_="" ns3:_="">
     <xsd:import namespace="0cd93fe2-0880-41f5-aab4-f958682b72cb"/>
@@ -10568,15 +10491,16 @@
 </ct:contentTypeSchema>
 </file>
 
-<file path=customXml/itemProps1.xml><?xml version="1.0" encoding="utf-8"?>
-<ds:datastoreItem xmlns:ds="http://schemas.openxmlformats.org/officeDocument/2006/customXml" ds:itemID="{A4661556-5590-415F-9315-F9BACBDA7B81}">
-  <ds:schemaRefs>
-    <ds:schemaRef ds:uri="http://schemas.microsoft.com/sharepoint/v3/contenttype/forms"/>
-  </ds:schemaRefs>
-</ds:datastoreItem>
+<file path=customXml/item2.xml><?xml version="1.0" encoding="utf-8"?>
+<?mso-contentType ?>
+<FormTemplates xmlns="http://schemas.microsoft.com/sharepoint/v3/contenttype/forms">
+  <Display>DocumentLibraryForm</Display>
+  <Edit>DocumentLibraryForm</Edit>
+  <New>DocumentLibraryForm</New>
+</FormTemplates>
 </file>
 
-<file path=customXml/itemProps2.xml><?xml version="1.0" encoding="utf-8"?>
+<file path=customXml/itemProps1.xml><?xml version="1.0" encoding="utf-8"?>
 <ds:datastoreItem xmlns:ds="http://schemas.openxmlformats.org/officeDocument/2006/customXml" ds:itemID="{CEB3752F-42B6-452F-9AAE-531B32224585}">
   <ds:schemaRefs>
     <ds:schemaRef ds:uri="http://schemas.microsoft.com/office/2006/metadata/contentType"/>
@@ -10593,4 +10517,12 @@
     <ds:schemaRef ds:uri="http://schemas.microsoft.com/internal/obd"/>
   </ds:schemaRefs>
 </ds:datastoreItem>
+</file>
+
+<file path=customXml/itemProps2.xml><?xml version="1.0" encoding="utf-8"?>
+<ds:datastoreItem xmlns:ds="http://schemas.openxmlformats.org/officeDocument/2006/customXml" ds:itemID="{A4661556-5590-415F-9315-F9BACBDA7B81}">
+  <ds:schemaRefs>
+    <ds:schemaRef ds:uri="http://schemas.microsoft.com/sharepoint/v3/contenttype/forms"/>
+  </ds:schemaRefs>
+</ds:datastoreItem>
 </file>
</xml_diff>